<commit_message>
docs: replace accuracy chart slide with financial model slide in Sprint Review 2
Co-Authored-By: Claude Sonnet 5.5 <noreply@anthropic.com>
</commit_message>
<xml_diff>
--- a/docs/Ascend_Sprint_Review_2.pptx
+++ b/docs/Ascend_Sprint_Review_2.pptx
@@ -114,19 +114,19 @@
   <p:extLst>
     <p:ext uri="{521415D9-36F7-43E2-AB2F-B90AF26B5E84}">
       <p14:sectionLst xmlns:p14="http://schemas.microsoft.com/office/powerpoint/2010/main">
-        <p14:section name="Intro" id="{1e6c1f6f-5f2a-ed1d-c172-6e4aa65cd74a}">
+        <p14:section name="Intro" id="{b5629477-3391-82a5-7fe1-3fe3761b7d38}">
           <p14:sldIdLst>
             <p14:sldId id="256"/>
           </p14:sldIdLst>
         </p14:section>
-        <p14:section name="Progress" id="{f873bd2d-87a1-28fc-6202-b2c83affde5b}">
+        <p14:section name="Progress" id="{0347600a-8f8c-eca5-4adc-05e90e701b0b}">
           <p14:sldIdLst>
             <p14:sldId id="257"/>
             <p14:sldId id="258"/>
             <p14:sldId id="259"/>
           </p14:sldIdLst>
         </p14:section>
-        <p14:section name="Plan" id="{8dd44c81-7781-621c-2bd5-ada9644aa0ac}">
+        <p14:section name="Plan" id="{67592457-21e2-fc5b-532b-f18d76594bef}">
           <p14:sldIdLst>
             <p14:sldId id="260"/>
             <p14:sldId id="261"/>
@@ -141,368 +141,6 @@
     </p:ext>
   </p:extLst>
 </p:presentation>
-</file>
-
-<file path=ppt/charts/chart1.xml><?xml version="1.0" encoding="utf-8"?>
-<c:chartSpace xmlns:c="http://schemas.openxmlformats.org/drawingml/2006/chart" xmlns:a="http://schemas.openxmlformats.org/drawingml/2006/main" xmlns:r="http://schemas.openxmlformats.org/officeDocument/2006/relationships">
-  <c:date1904 val="0"/>
-  <c:roundedCorners val="1"/>
-  <c:chart>
-    <c:title>
-      <c:tx>
-        <c:rich>
-          <a:bodyPr/>
-          <a:lstStyle/>
-          <a:p>
-            <a:pPr>
-              <a:defRPr sz="1400" b="0" i="0" u="none" strike="noStrike">
-                <a:solidFill>
-                  <a:srgbClr val="161C19"/>
-                </a:solidFill>
-                <a:latin typeface="+mn-lt"/>
-              </a:defRPr>
-            </a:pPr>
-            <a:r>
-              <a:rPr sz="1400" b="0" i="0" u="none" strike="noStrike">
-                <a:solidFill>
-                  <a:srgbClr val="161C19"/>
-                </a:solidFill>
-                <a:latin typeface="+mn-lt"/>
-              </a:rPr>
-              <a:t>Average monthly miss, % (lower is better)</a:t>
-            </a:r>
-          </a:p>
-        </c:rich>
-      </c:tx>
-      <c:layout/>
-      <c:overlay val="0"/>
-    </c:title>
-    <c:autoTitleDeleted val="0"/>
-    <c:plotArea>
-      <c:layout/>
-      <c:barChart>
-        <c:barDir val="col"/>
-        <c:grouping val="clustered"/>
-        <c:varyColors val="0"/>
-        <c:ser>
-          <c:idx val="0"/>
-          <c:order val="0"/>
-          <c:tx>
-            <c:strRef>
-              <c:f>Sheet1!$B$1</c:f>
-              <c:strCache>
-                <c:ptCount val="1"/>
-                <c:pt idx="0">
-                  <c:v>Ascend</c:v>
-                </c:pt>
-              </c:strCache>
-            </c:strRef>
-          </c:tx>
-          <c:spPr>
-            <a:solidFill>
-              <a:srgbClr val="1F6B4F"/>
-            </a:solidFill>
-            <a:effectLst/>
-          </c:spPr>
-          <c:invertIfNegative val="0"/>
-          <c:dLbls>
-            <c:numFmt formatCode="0.0" sourceLinked="0"/>
-            <c:txPr>
-              <a:bodyPr/>
-              <a:lstStyle/>
-              <a:p>
-                <a:pPr>
-                  <a:defRPr b="0" i="0" strike="noStrike" sz="1400" u="none">
-                    <a:solidFill>
-                      <a:srgbClr val="161C19"/>
-                    </a:solidFill>
-                    <a:latin typeface="+mn-lt"/>
-                  </a:defRPr>
-                </a:pPr>
-              </a:p>
-            </c:txPr>
-            <c:showLegendKey val="0"/>
-            <c:showVal val="1"/>
-            <c:showCatName val="0"/>
-            <c:showSerName val="0"/>
-            <c:showPercent val="0"/>
-            <c:showBubbleSize val="0"/>
-            <c:showLeaderLines val="0"/>
-          </c:dLbls>
-          <c:cat>
-            <c:multiLvlStrRef>
-              <c:f>Sheet1!$A$2:$A$3</c:f>
-              <c:multiLvlStrCache>
-                <c:ptCount val="2"/>
-                <c:lvl>
-                  <c:pt idx="0">
-                    <c:v>36 months of history</c:v>
-                  </c:pt>
-                  <c:pt idx="1">
-                    <c:v>18 months of history</c:v>
-                  </c:pt>
-                </c:lvl>
-              </c:multiLvlStrCache>
-            </c:multiLvlStrRef>
-          </c:cat>
-          <c:val>
-            <c:numRef>
-              <c:f>Sheet1!$B$2:$B$3</c:f>
-              <c:numCache>
-                <c:formatCode>General</c:formatCode>
-                <c:ptCount val="2"/>
-                <c:pt idx="0">
-                  <c:v>4.6</c:v>
-                </c:pt>
-                <c:pt idx="1">
-                  <c:v>5</c:v>
-                </c:pt>
-              </c:numCache>
-            </c:numRef>
-          </c:val>
-        </c:ser>
-        <c:ser>
-          <c:idx val="1"/>
-          <c:order val="1"/>
-          <c:tx>
-            <c:strRef>
-              <c:f>Sheet1!$C$1</c:f>
-              <c:strCache>
-                <c:ptCount val="1"/>
-                <c:pt idx="0">
-                  <c:v>Same month last year</c:v>
-                </c:pt>
-              </c:strCache>
-            </c:strRef>
-          </c:tx>
-          <c:spPr>
-            <a:solidFill>
-              <a:srgbClr val="D6DCD7"/>
-            </a:solidFill>
-            <a:effectLst/>
-          </c:spPr>
-          <c:invertIfNegative val="0"/>
-          <c:dLbls>
-            <c:numFmt formatCode="0.0" sourceLinked="0"/>
-            <c:txPr>
-              <a:bodyPr/>
-              <a:lstStyle/>
-              <a:p>
-                <a:pPr>
-                  <a:defRPr b="0" i="0" strike="noStrike" sz="1400" u="none">
-                    <a:solidFill>
-                      <a:srgbClr val="161C19"/>
-                    </a:solidFill>
-                    <a:latin typeface="+mn-lt"/>
-                  </a:defRPr>
-                </a:pPr>
-              </a:p>
-            </c:txPr>
-            <c:showLegendKey val="0"/>
-            <c:showVal val="1"/>
-            <c:showCatName val="0"/>
-            <c:showSerName val="0"/>
-            <c:showPercent val="0"/>
-            <c:showBubbleSize val="0"/>
-            <c:showLeaderLines val="0"/>
-          </c:dLbls>
-          <c:cat>
-            <c:multiLvlStrRef>
-              <c:f>Sheet1!$A$2:$A$3</c:f>
-              <c:multiLvlStrCache>
-                <c:ptCount val="2"/>
-                <c:lvl>
-                  <c:pt idx="0">
-                    <c:v>36 months of history</c:v>
-                  </c:pt>
-                  <c:pt idx="1">
-                    <c:v>18 months of history</c:v>
-                  </c:pt>
-                </c:lvl>
-              </c:multiLvlStrCache>
-            </c:multiLvlStrRef>
-          </c:cat>
-          <c:val>
-            <c:numRef>
-              <c:f>Sheet1!$C$2:$C$3</c:f>
-              <c:numCache>
-                <c:formatCode>General</c:formatCode>
-                <c:ptCount val="2"/>
-                <c:pt idx="0">
-                  <c:v>6.4</c:v>
-                </c:pt>
-                <c:pt idx="1">
-                  <c:v>6.4</c:v>
-                </c:pt>
-              </c:numCache>
-            </c:numRef>
-          </c:val>
-        </c:ser>
-        <c:dLbls>
-          <c:numFmt formatCode="0.0" sourceLinked="0"/>
-          <c:txPr>
-            <a:bodyPr/>
-            <a:lstStyle/>
-            <a:p>
-              <a:pPr>
-                <a:defRPr b="0" i="0" strike="noStrike" sz="1400" u="none">
-                  <a:solidFill>
-                    <a:srgbClr val="161C19"/>
-                  </a:solidFill>
-                  <a:latin typeface="+mn-lt"/>
-                </a:defRPr>
-              </a:pPr>
-            </a:p>
-          </c:txPr>
-          <c:showLegendKey val="0"/>
-          <c:showVal val="1"/>
-          <c:showCatName val="0"/>
-          <c:showSerName val="0"/>
-          <c:showPercent val="0"/>
-          <c:showBubbleSize val="0"/>
-          <c:showLeaderLines val="0"/>
-        </c:dLbls>
-        <c:gapWidth val="60"/>
-        <c:overlap val="0"/>
-        <c:axId val="2094734554"/>
-        <c:axId val="2094734552"/>
-        <c:axId val="2094734556"/>
-      </c:barChart>
-      <c:catAx>
-        <c:axId val="2094734554"/>
-        <c:scaling>
-          <c:orientation val="minMax"/>
-        </c:scaling>
-        <c:delete val="0"/>
-        <c:axPos val="b"/>
-        <c:numFmt formatCode="General" sourceLinked="1"/>
-        <c:majorTickMark val="out"/>
-        <c:minorTickMark val="none"/>
-        <c:tickLblPos val="low"/>
-        <c:spPr>
-          <a:ln w="12700" cap="flat">
-            <a:solidFill>
-              <a:srgbClr val="888888"/>
-            </a:solidFill>
-            <a:prstDash val="solid"/>
-            <a:round/>
-          </a:ln>
-        </c:spPr>
-        <c:txPr>
-          <a:bodyPr/>
-          <a:lstStyle/>
-          <a:p>
-            <a:pPr>
-              <a:defRPr sz="1300" b="0" i="0" u="none" strike="noStrike">
-                <a:solidFill>
-                  <a:srgbClr val="161C19"/>
-                </a:solidFill>
-                <a:latin typeface="+mn-lt"/>
-              </a:defRPr>
-            </a:pPr>
-            <a:endParaRPr lang="en-US"/>
-          </a:p>
-        </c:txPr>
-        <c:crossAx val="2094734552"/>
-        <c:crosses val="autoZero"/>
-        <c:auto val="1"/>
-        <c:lblAlgn val="ctr"/>
-        <c:noMultiLvlLbl val="1"/>
-      </c:catAx>
-      <c:valAx>
-        <c:axId val="2094734552"/>
-        <c:scaling>
-          <c:orientation val="minMax"/>
-          <c:max val="8"/>
-          <c:min val="0"/>
-        </c:scaling>
-        <c:delete val="0"/>
-        <c:axPos val="l"/>
-        <c:majorGridlines>
-          <c:spPr>
-            <a:ln w="6350" cap="flat">
-              <a:solidFill>
-                <a:srgbClr val="D6DCD7"/>
-              </a:solidFill>
-              <a:prstDash val="solid"/>
-              <a:round/>
-            </a:ln>
-          </c:spPr>
-        </c:majorGridlines>
-        <c:numFmt formatCode="General" sourceLinked="0"/>
-        <c:majorTickMark val="out"/>
-        <c:minorTickMark val="none"/>
-        <c:tickLblPos val="nextTo"/>
-        <c:spPr>
-          <a:ln w="12700" cap="flat">
-            <a:solidFill>
-              <a:srgbClr val="888888"/>
-            </a:solidFill>
-            <a:prstDash val="solid"/>
-            <a:round/>
-          </a:ln>
-        </c:spPr>
-        <c:txPr>
-          <a:bodyPr/>
-          <a:lstStyle/>
-          <a:p>
-            <a:pPr>
-              <a:defRPr sz="1100" b="0" i="0" u="none" strike="noStrike">
-                <a:solidFill>
-                  <a:srgbClr val="6B7671"/>
-                </a:solidFill>
-                <a:latin typeface="+mn-lt"/>
-              </a:defRPr>
-            </a:pPr>
-            <a:endParaRPr lang="en-US"/>
-          </a:p>
-        </c:txPr>
-        <c:crossAx val="2094734554"/>
-        <c:crosses val="autoZero"/>
-        <c:crossBetween val="between"/>
-      </c:valAx>
-      <c:spPr>
-        <a:noFill/>
-        <a:ln>
-          <a:noFill/>
-        </a:ln>
-        <a:effectLst/>
-      </c:spPr>
-    </c:plotArea>
-    <c:legend>
-      <c:legendPos val="b"/>
-      <c:overlay val="0"/>
-      <c:txPr>
-        <a:bodyPr/>
-        <a:lstStyle/>
-        <a:p>
-          <a:pPr>
-            <a:defRPr sz="1200">
-              <a:solidFill>
-                <a:srgbClr val="161C19"/>
-              </a:solidFill>
-              <a:latin typeface="+mn-lt"/>
-              <a:cs typeface="+mn-lt"/>
-            </a:defRPr>
-          </a:pPr>
-          <a:endParaRPr lang="en-US"/>
-        </a:p>
-      </c:txPr>
-    </c:legend>
-    <c:plotVisOnly val="1"/>
-    <c:dispBlanksAs val="span"/>
-  </c:chart>
-  <c:spPr>
-    <a:noFill/>
-    <a:ln>
-      <a:noFill/>
-    </a:ln>
-    <a:effectLst/>
-  </c:spPr>
-  <c:externalData r:id="rId1">
-    <c:autoUpdate val="0"/>
-  </c:externalData>
-</c:chartSpace>
 </file>
 
 <file path=ppt/notesMasters/notesMaster1.xml><?xml version="1.0" encoding="utf-8"?>
@@ -1164,7 +802,7 @@
           <a:p>
             <a:r>
               <a:rPr lang="en-US" dirty="0"/>
-              <a:t>We re-ran our backtest on 31 real public series: the US Census retail series by store type, airline passengers and Quebec car sales. At many past dates the model saw only the last 36 or 18 months and forecast the next 12, then we scored it against what really happened. The naive baseline is "same month last year". Be upfront: these are national totals, which are smoother than one shop, so a single business will usually score lower. That is why the app shows each client a test on their own recent months.</a:t>
+              <a:t>Three parts. First, three standard statistical methods are averaged. Second, our own patch-based transformer, in the style of PatchTST, reads the last 36 months in 3-month patches and learns a correction to a last-year-scaled baseline; it is trained on 48,000 real monthly series from the M4 competition plus US retail data, and it only runs when there are 36 or more months of history. It is blended 50/50 with the statistical forecast. Third, a Monte Carlo runs the forecast 3,000 times with realistic randomness; the spread is the likely range and it also feeds the value estimate. The bottom numbers come from our backtest on 31 public series (US Census retail by store type, airline passengers, Quebec car sales), 2,652 forecasts at 36 months of history. These are national totals, smoother than one shop, so a single business will usually score lower; the app shows each client a test on their own recent months.</a:t>
             </a:r>
             <a:endParaRPr lang="en-US" dirty="0"/>
           </a:p>
@@ -4208,42 +3846,26 @@
                   <a:schemeClr val="tx1"/>
                 </a:solidFill>
               </a:rPr>
-              <a:t>How accurate is the forecast</a:t>
+              <a:t>How the financial model works</a:t>
             </a:r>
             <a:endParaRPr lang="en-US" sz="3400" dirty="0"/>
           </a:p>
         </p:txBody>
       </p:sp>
-      <p:graphicFrame>
-        <p:nvGraphicFramePr>
-          <p:cNvPr id="5" name="Chart 0" descr=""/>
-          <p:cNvGraphicFramePr/>
-          <p:nvPr/>
-        </p:nvGraphicFramePr>
-        <p:xfrm>
-          <a:off x="548640" y="1691640"/>
-          <a:ext cx="6400800" cy="4297680"/>
-        </p:xfrm>
-        <a:graphic xmlns:a="http://schemas.openxmlformats.org/drawingml/2006/main">
-          <a:graphicData uri="http://schemas.openxmlformats.org/drawingml/2006/chart">
-            <c:chart xmlns:c="http://schemas.openxmlformats.org/drawingml/2006/chart" r:id="rId1"/>
-          </a:graphicData>
-        </a:graphic>
-      </p:graphicFrame>
-      <p:sp>
-        <p:nvSpPr>
-          <p:cNvPr id="6" name="Reading card"/>
+      <p:sp>
+        <p:nvSpPr>
+          <p:cNvPr id="5" name="Model part 1"/>
           <p:cNvSpPr/>
           <p:nvPr/>
         </p:nvSpPr>
         <p:spPr>
           <a:xfrm>
-            <a:off x="7315200" y="1691640"/>
-            <a:ext cx="4343400" cy="4297680"/>
+            <a:off x="548640" y="1691640"/>
+            <a:ext cx="3383280" cy="2286000"/>
           </a:xfrm>
           <a:prstGeom prst="roundRect">
             <a:avLst>
-              <a:gd name="adj" fmla="val 2553"/>
+              <a:gd name="adj" fmla="val 4800"/>
             </a:avLst>
           </a:prstGeom>
           <a:solidFill>
@@ -4259,14 +3881,75 @@
       </p:sp>
       <p:sp>
         <p:nvSpPr>
-          <p:cNvPr id="7" name="Text 3"/>
-          <p:cNvSpPr txBox="1"/>
-          <p:nvPr/>
-        </p:nvSpPr>
-        <p:spPr>
-          <a:xfrm>
-            <a:off x="7589520" y="1874520"/>
-            <a:ext cx="3840480" cy="365760"/>
+          <p:cNvPr id="6" name="Part 1 badge"/>
+          <p:cNvSpPr/>
+          <p:nvPr/>
+        </p:nvSpPr>
+        <p:spPr>
+          <a:xfrm>
+            <a:off x="777240" y="1828800"/>
+            <a:ext cx="457200" cy="457200"/>
+          </a:xfrm>
+          <a:prstGeom prst="ellipse">
+            <a:avLst/>
+          </a:prstGeom>
+          <a:solidFill>
+            <a:schemeClr val="accent1"/>
+          </a:solidFill>
+          <a:ln w="6350">
+            <a:solidFill>
+              <a:schemeClr val="accent1"/>
+            </a:solidFill>
+            <a:prstDash val="solid"/>
+          </a:ln>
+        </p:spPr>
+      </p:sp>
+      <p:sp>
+        <p:nvSpPr>
+          <p:cNvPr id="7" name="Text 4"/>
+          <p:cNvSpPr txBox="1"/>
+          <p:nvPr/>
+        </p:nvSpPr>
+        <p:spPr>
+          <a:xfrm>
+            <a:off x="777240" y="1828800"/>
+            <a:ext cx="457200" cy="457200"/>
+          </a:xfrm>
+          <a:prstGeom prst="rect">
+            <a:avLst/>
+          </a:prstGeom>
+          <a:noFill/>
+          <a:ln/>
+        </p:spPr>
+        <p:txBody>
+          <a:bodyPr wrap="square" lIns="0" tIns="0" rIns="0" bIns="0" rtlCol="0" anchor="ctr"/>
+          <a:lstStyle/>
+          <a:p>
+            <a:pPr algn="ctr" indent="0" marL="0">
+              <a:buNone/>
+            </a:pPr>
+            <a:r>
+              <a:rPr lang="en-US" sz="1600" b="1" dirty="0">
+                <a:solidFill>
+                  <a:schemeClr val="bg1"/>
+                </a:solidFill>
+              </a:rPr>
+              <a:t>1</a:t>
+            </a:r>
+            <a:endParaRPr lang="en-US" sz="1600" dirty="0"/>
+          </a:p>
+        </p:txBody>
+      </p:sp>
+      <p:sp>
+        <p:nvSpPr>
+          <p:cNvPr id="8" name="Text 5"/>
+          <p:cNvSpPr txBox="1"/>
+          <p:nvPr/>
+        </p:nvSpPr>
+        <p:spPr>
+          <a:xfrm>
+            <a:off x="1417320" y="1828800"/>
+            <a:ext cx="2377440" cy="457200"/>
           </a:xfrm>
           <a:prstGeom prst="rect">
             <a:avLst/>
@@ -4287,7 +3970,7 @@
                   <a:schemeClr val="tx1"/>
                 </a:solidFill>
               </a:rPr>
-              <a:t>What this tells us</a:t>
+              <a:t>Statistical forecast</a:t>
             </a:r>
             <a:endParaRPr lang="en-US" sz="1800" dirty="0"/>
           </a:p>
@@ -4295,14 +3978,14 @@
       </p:sp>
       <p:sp>
         <p:nvSpPr>
-          <p:cNvPr id="8" name="Text 4"/>
-          <p:cNvSpPr txBox="1"/>
-          <p:nvPr/>
-        </p:nvSpPr>
-        <p:spPr>
-          <a:xfrm>
-            <a:off x="7589520" y="2377440"/>
-            <a:ext cx="3840480" cy="3474720"/>
+          <p:cNvPr id="9" name="Text 6"/>
+          <p:cNvSpPr txBox="1"/>
+          <p:nvPr/>
+        </p:nvSpPr>
+        <p:spPr>
+          <a:xfrm>
+            <a:off x="777240" y="2468880"/>
+            <a:ext cx="2926080" cy="1371600"/>
           </a:xfrm>
           <a:prstGeom prst="rect">
             <a:avLst/>
@@ -4314,74 +3997,665 @@
           <a:bodyPr wrap="square" lIns="0" tIns="0" rIns="0" bIns="0" rtlCol="0" anchor="t"/>
           <a:lstStyle/>
           <a:p>
-            <a:pPr marL="342900" indent="-342900">
-              <a:spcAft>
-                <a:spcPts val="800"/>
-              </a:spcAft>
-              <a:buSzPct val="100000"/>
-              <a:buChar char="•"/>
+            <a:pPr indent="0" marL="0">
+              <a:buNone/>
+            </a:pPr>
+            <a:r>
+              <a:rPr lang="en-US" sz="1500" dirty="0">
+                <a:solidFill>
+                  <a:schemeClr val="tx2"/>
+                </a:solidFill>
+              </a:rPr>
+              <a:t>Three proven methods averaged: seasonal smoothing, last year scaled by growth, and Theta.</a:t>
+            </a:r>
+            <a:endParaRPr lang="en-US" sz="1500" dirty="0"/>
+          </a:p>
+        </p:txBody>
+      </p:sp>
+      <p:sp>
+        <p:nvSpPr>
+          <p:cNvPr id="10" name="Model arrow 1"/>
+          <p:cNvSpPr/>
+          <p:nvPr/>
+        </p:nvSpPr>
+        <p:spPr>
+          <a:xfrm>
+            <a:off x="3986784" y="2651760"/>
+            <a:ext cx="347472" cy="411480"/>
+          </a:xfrm>
+          <a:prstGeom prst="rightArrow">
+            <a:avLst/>
+          </a:prstGeom>
+          <a:solidFill>
+            <a:schemeClr val="accent2"/>
+          </a:solidFill>
+          <a:ln w="6350">
+            <a:solidFill>
+              <a:schemeClr val="accent2"/>
+            </a:solidFill>
+            <a:prstDash val="solid"/>
+          </a:ln>
+        </p:spPr>
+      </p:sp>
+      <p:sp>
+        <p:nvSpPr>
+          <p:cNvPr id="11" name="Model part 2"/>
+          <p:cNvSpPr/>
+          <p:nvPr/>
+        </p:nvSpPr>
+        <p:spPr>
+          <a:xfrm>
+            <a:off x="4389120" y="1691640"/>
+            <a:ext cx="3383280" cy="2286000"/>
+          </a:xfrm>
+          <a:prstGeom prst="roundRect">
+            <a:avLst>
+              <a:gd name="adj" fmla="val 4800"/>
+            </a:avLst>
+          </a:prstGeom>
+          <a:solidFill>
+            <a:schemeClr val="bg2"/>
+          </a:solidFill>
+          <a:ln w="6350">
+            <a:solidFill>
+              <a:schemeClr val="bg2"/>
+            </a:solidFill>
+            <a:prstDash val="solid"/>
+          </a:ln>
+        </p:spPr>
+      </p:sp>
+      <p:sp>
+        <p:nvSpPr>
+          <p:cNvPr id="12" name="Part 2 badge"/>
+          <p:cNvSpPr/>
+          <p:nvPr/>
+        </p:nvSpPr>
+        <p:spPr>
+          <a:xfrm>
+            <a:off x="4617720" y="1828800"/>
+            <a:ext cx="457200" cy="457200"/>
+          </a:xfrm>
+          <a:prstGeom prst="ellipse">
+            <a:avLst/>
+          </a:prstGeom>
+          <a:solidFill>
+            <a:schemeClr val="accent1"/>
+          </a:solidFill>
+          <a:ln w="6350">
+            <a:solidFill>
+              <a:schemeClr val="accent1"/>
+            </a:solidFill>
+            <a:prstDash val="solid"/>
+          </a:ln>
+        </p:spPr>
+      </p:sp>
+      <p:sp>
+        <p:nvSpPr>
+          <p:cNvPr id="13" name="Text 10"/>
+          <p:cNvSpPr txBox="1"/>
+          <p:nvPr/>
+        </p:nvSpPr>
+        <p:spPr>
+          <a:xfrm>
+            <a:off x="4617720" y="1828800"/>
+            <a:ext cx="457200" cy="457200"/>
+          </a:xfrm>
+          <a:prstGeom prst="rect">
+            <a:avLst/>
+          </a:prstGeom>
+          <a:noFill/>
+          <a:ln/>
+        </p:spPr>
+        <p:txBody>
+          <a:bodyPr wrap="square" lIns="0" tIns="0" rIns="0" bIns="0" rtlCol="0" anchor="ctr"/>
+          <a:lstStyle/>
+          <a:p>
+            <a:pPr algn="ctr" indent="0" marL="0">
+              <a:buNone/>
+            </a:pPr>
+            <a:r>
+              <a:rPr lang="en-US" sz="1600" b="1" dirty="0">
+                <a:solidFill>
+                  <a:schemeClr val="bg1"/>
+                </a:solidFill>
+              </a:rPr>
+              <a:t>2</a:t>
+            </a:r>
+            <a:endParaRPr lang="en-US" sz="1600" dirty="0"/>
+          </a:p>
+        </p:txBody>
+      </p:sp>
+      <p:sp>
+        <p:nvSpPr>
+          <p:cNvPr id="14" name="Text 11"/>
+          <p:cNvSpPr txBox="1"/>
+          <p:nvPr/>
+        </p:nvSpPr>
+        <p:spPr>
+          <a:xfrm>
+            <a:off x="5257800" y="1828800"/>
+            <a:ext cx="2377440" cy="457200"/>
+          </a:xfrm>
+          <a:prstGeom prst="rect">
+            <a:avLst/>
+          </a:prstGeom>
+          <a:noFill/>
+          <a:ln/>
+        </p:spPr>
+        <p:txBody>
+          <a:bodyPr wrap="square" lIns="0" tIns="0" rIns="0" bIns="0" rtlCol="0" anchor="ctr"/>
+          <a:lstStyle/>
+          <a:p>
+            <a:pPr indent="0" marL="0">
+              <a:buNone/>
+            </a:pPr>
+            <a:r>
+              <a:rPr lang="en-US" sz="1800" b="1" dirty="0">
+                <a:solidFill>
+                  <a:schemeClr val="tx1"/>
+                </a:solidFill>
+              </a:rPr>
+              <a:t>Patch transformer</a:t>
+            </a:r>
+            <a:endParaRPr lang="en-US" sz="1800" dirty="0"/>
+          </a:p>
+        </p:txBody>
+      </p:sp>
+      <p:sp>
+        <p:nvSpPr>
+          <p:cNvPr id="15" name="Text 12"/>
+          <p:cNvSpPr txBox="1"/>
+          <p:nvPr/>
+        </p:nvSpPr>
+        <p:spPr>
+          <a:xfrm>
+            <a:off x="4617720" y="2468880"/>
+            <a:ext cx="2926080" cy="1371600"/>
+          </a:xfrm>
+          <a:prstGeom prst="rect">
+            <a:avLst/>
+          </a:prstGeom>
+          <a:noFill/>
+          <a:ln/>
+        </p:spPr>
+        <p:txBody>
+          <a:bodyPr wrap="square" lIns="0" tIns="0" rIns="0" bIns="0" rtlCol="0" anchor="t"/>
+          <a:lstStyle/>
+          <a:p>
+            <a:pPr indent="0" marL="0">
+              <a:buNone/>
+            </a:pPr>
+            <a:r>
+              <a:rPr lang="en-US" sz="1500" dirty="0">
+                <a:solidFill>
+                  <a:schemeClr val="tx2"/>
+                </a:solidFill>
+              </a:rPr>
+              <a:t>A small PatchTST-style model reads your last 36 months in 3-month patches and corrects the baseline. Trained on 48,000 real series.</a:t>
+            </a:r>
+            <a:endParaRPr lang="en-US" sz="1500" dirty="0"/>
+          </a:p>
+        </p:txBody>
+      </p:sp>
+      <p:sp>
+        <p:nvSpPr>
+          <p:cNvPr id="16" name="Model arrow 2"/>
+          <p:cNvSpPr/>
+          <p:nvPr/>
+        </p:nvSpPr>
+        <p:spPr>
+          <a:xfrm>
+            <a:off x="7827264" y="2651760"/>
+            <a:ext cx="347472" cy="411480"/>
+          </a:xfrm>
+          <a:prstGeom prst="rightArrow">
+            <a:avLst/>
+          </a:prstGeom>
+          <a:solidFill>
+            <a:schemeClr val="accent2"/>
+          </a:solidFill>
+          <a:ln w="6350">
+            <a:solidFill>
+              <a:schemeClr val="accent2"/>
+            </a:solidFill>
+            <a:prstDash val="solid"/>
+          </a:ln>
+        </p:spPr>
+      </p:sp>
+      <p:sp>
+        <p:nvSpPr>
+          <p:cNvPr id="17" name="Model part 3"/>
+          <p:cNvSpPr/>
+          <p:nvPr/>
+        </p:nvSpPr>
+        <p:spPr>
+          <a:xfrm>
+            <a:off x="8229600" y="1691640"/>
+            <a:ext cx="3383280" cy="2286000"/>
+          </a:xfrm>
+          <a:prstGeom prst="roundRect">
+            <a:avLst>
+              <a:gd name="adj" fmla="val 4800"/>
+            </a:avLst>
+          </a:prstGeom>
+          <a:solidFill>
+            <a:schemeClr val="bg2"/>
+          </a:solidFill>
+          <a:ln w="6350">
+            <a:solidFill>
+              <a:schemeClr val="bg2"/>
+            </a:solidFill>
+            <a:prstDash val="solid"/>
+          </a:ln>
+        </p:spPr>
+      </p:sp>
+      <p:sp>
+        <p:nvSpPr>
+          <p:cNvPr id="18" name="Part 3 badge"/>
+          <p:cNvSpPr/>
+          <p:nvPr/>
+        </p:nvSpPr>
+        <p:spPr>
+          <a:xfrm>
+            <a:off x="8458200" y="1828800"/>
+            <a:ext cx="457200" cy="457200"/>
+          </a:xfrm>
+          <a:prstGeom prst="ellipse">
+            <a:avLst/>
+          </a:prstGeom>
+          <a:solidFill>
+            <a:schemeClr val="accent1"/>
+          </a:solidFill>
+          <a:ln w="6350">
+            <a:solidFill>
+              <a:schemeClr val="accent1"/>
+            </a:solidFill>
+            <a:prstDash val="solid"/>
+          </a:ln>
+        </p:spPr>
+      </p:sp>
+      <p:sp>
+        <p:nvSpPr>
+          <p:cNvPr id="19" name="Text 16"/>
+          <p:cNvSpPr txBox="1"/>
+          <p:nvPr/>
+        </p:nvSpPr>
+        <p:spPr>
+          <a:xfrm>
+            <a:off x="8458200" y="1828800"/>
+            <a:ext cx="457200" cy="457200"/>
+          </a:xfrm>
+          <a:prstGeom prst="rect">
+            <a:avLst/>
+          </a:prstGeom>
+          <a:noFill/>
+          <a:ln/>
+        </p:spPr>
+        <p:txBody>
+          <a:bodyPr wrap="square" lIns="0" tIns="0" rIns="0" bIns="0" rtlCol="0" anchor="ctr"/>
+          <a:lstStyle/>
+          <a:p>
+            <a:pPr algn="ctr" indent="0" marL="0">
+              <a:buNone/>
+            </a:pPr>
+            <a:r>
+              <a:rPr lang="en-US" sz="1600" b="1" dirty="0">
+                <a:solidFill>
+                  <a:schemeClr val="bg1"/>
+                </a:solidFill>
+              </a:rPr>
+              <a:t>3</a:t>
+            </a:r>
+            <a:endParaRPr lang="en-US" sz="1600" dirty="0"/>
+          </a:p>
+        </p:txBody>
+      </p:sp>
+      <p:sp>
+        <p:nvSpPr>
+          <p:cNvPr id="20" name="Text 17"/>
+          <p:cNvSpPr txBox="1"/>
+          <p:nvPr/>
+        </p:nvSpPr>
+        <p:spPr>
+          <a:xfrm>
+            <a:off x="9098280" y="1828800"/>
+            <a:ext cx="2377440" cy="457200"/>
+          </a:xfrm>
+          <a:prstGeom prst="rect">
+            <a:avLst/>
+          </a:prstGeom>
+          <a:noFill/>
+          <a:ln/>
+        </p:spPr>
+        <p:txBody>
+          <a:bodyPr wrap="square" lIns="0" tIns="0" rIns="0" bIns="0" rtlCol="0" anchor="ctr"/>
+          <a:lstStyle/>
+          <a:p>
+            <a:pPr indent="0" marL="0">
+              <a:buNone/>
+            </a:pPr>
+            <a:r>
+              <a:rPr lang="en-US" sz="1800" b="1" dirty="0">
+                <a:solidFill>
+                  <a:schemeClr val="tx1"/>
+                </a:solidFill>
+              </a:rPr>
+              <a:t>Monte Carlo</a:t>
+            </a:r>
+            <a:endParaRPr lang="en-US" sz="1800" dirty="0"/>
+          </a:p>
+        </p:txBody>
+      </p:sp>
+      <p:sp>
+        <p:nvSpPr>
+          <p:cNvPr id="21" name="Text 18"/>
+          <p:cNvSpPr txBox="1"/>
+          <p:nvPr/>
+        </p:nvSpPr>
+        <p:spPr>
+          <a:xfrm>
+            <a:off x="8458200" y="2468880"/>
+            <a:ext cx="2926080" cy="1371600"/>
+          </a:xfrm>
+          <a:prstGeom prst="rect">
+            <a:avLst/>
+          </a:prstGeom>
+          <a:noFill/>
+          <a:ln/>
+        </p:spPr>
+        <p:txBody>
+          <a:bodyPr wrap="square" lIns="0" tIns="0" rIns="0" bIns="0" rtlCol="0" anchor="t"/>
+          <a:lstStyle/>
+          <a:p>
+            <a:pPr indent="0" marL="0">
+              <a:buNone/>
+            </a:pPr>
+            <a:r>
+              <a:rPr lang="en-US" sz="1500" dirty="0">
+                <a:solidFill>
+                  <a:schemeClr val="tx2"/>
+                </a:solidFill>
+              </a:rPr>
+              <a:t>Runs the forecast 3,000 times with realistic randomness. The spread of results is your likely range, and it feeds the value estimate.</a:t>
+            </a:r>
+            <a:endParaRPr lang="en-US" sz="1500" dirty="0"/>
+          </a:p>
+        </p:txBody>
+      </p:sp>
+      <p:sp>
+        <p:nvSpPr>
+          <p:cNvPr id="22" name="Text 19"/>
+          <p:cNvSpPr txBox="1"/>
+          <p:nvPr/>
+        </p:nvSpPr>
+        <p:spPr>
+          <a:xfrm>
+            <a:off x="548640" y="4206240"/>
+            <a:ext cx="11064240" cy="365760"/>
+          </a:xfrm>
+          <a:prstGeom prst="rect">
+            <a:avLst/>
+          </a:prstGeom>
+          <a:noFill/>
+          <a:ln/>
+        </p:spPr>
+        <p:txBody>
+          <a:bodyPr wrap="square" lIns="0" tIns="0" rIns="0" bIns="0" rtlCol="0" anchor="ctr"/>
+          <a:lstStyle/>
+          <a:p>
+            <a:pPr indent="0" marL="0">
+              <a:buNone/>
+            </a:pPr>
+            <a:r>
+              <a:rPr lang="en-US" sz="1600" i="1" dirty="0">
+                <a:solidFill>
+                  <a:schemeClr val="tx2"/>
+                </a:solidFill>
+              </a:rPr>
+              <a:t>Result: the next 12 months with a likely range, a value estimate, and answers to what-if questions.</a:t>
+            </a:r>
+            <a:endParaRPr lang="en-US" sz="1600" dirty="0"/>
+          </a:p>
+        </p:txBody>
+      </p:sp>
+      <p:sp>
+        <p:nvSpPr>
+          <p:cNvPr id="23" name="Proof band"/>
+          <p:cNvSpPr/>
+          <p:nvPr/>
+        </p:nvSpPr>
+        <p:spPr>
+          <a:xfrm>
+            <a:off x="548640" y="4800600"/>
+            <a:ext cx="11109960" cy="1325880"/>
+          </a:xfrm>
+          <a:prstGeom prst="roundRect">
+            <a:avLst>
+              <a:gd name="adj" fmla="val 8276"/>
+            </a:avLst>
+          </a:prstGeom>
+          <a:solidFill>
+            <a:schemeClr val="accent1"/>
+          </a:solidFill>
+          <a:ln w="6350">
+            <a:solidFill>
+              <a:schemeClr val="accent1"/>
+            </a:solidFill>
+            <a:prstDash val="solid"/>
+          </a:ln>
+        </p:spPr>
+      </p:sp>
+      <p:sp>
+        <p:nvSpPr>
+          <p:cNvPr id="24" name="Text 21"/>
+          <p:cNvSpPr txBox="1"/>
+          <p:nvPr/>
+        </p:nvSpPr>
+        <p:spPr>
+          <a:xfrm>
+            <a:off x="777240" y="4956048"/>
+            <a:ext cx="3383280" cy="594360"/>
+          </a:xfrm>
+          <a:prstGeom prst="rect">
+            <a:avLst/>
+          </a:prstGeom>
+          <a:noFill/>
+          <a:ln/>
+        </p:spPr>
+        <p:txBody>
+          <a:bodyPr wrap="square" lIns="0" tIns="0" rIns="0" bIns="0" rtlCol="0" anchor="ctr"/>
+          <a:lstStyle/>
+          <a:p>
+            <a:pPr indent="0" marL="0">
+              <a:buNone/>
+            </a:pPr>
+            <a:r>
+              <a:rPr lang="en-US" sz="3200" b="1" dirty="0">
+                <a:solidFill>
+                  <a:schemeClr val="bg1"/>
+                </a:solidFill>
+              </a:rPr>
+              <a:t>95.4%</a:t>
+            </a:r>
+            <a:endParaRPr lang="en-US" sz="3200" dirty="0"/>
+          </a:p>
+        </p:txBody>
+      </p:sp>
+      <p:sp>
+        <p:nvSpPr>
+          <p:cNvPr id="25" name="Text 22"/>
+          <p:cNvSpPr txBox="1"/>
+          <p:nvPr/>
+        </p:nvSpPr>
+        <p:spPr>
+          <a:xfrm>
+            <a:off x="777240" y="5577840"/>
+            <a:ext cx="3383280" cy="365760"/>
+          </a:xfrm>
+          <a:prstGeom prst="rect">
+            <a:avLst/>
+          </a:prstGeom>
+          <a:noFill/>
+          <a:ln/>
+        </p:spPr>
+        <p:txBody>
+          <a:bodyPr wrap="square" lIns="0" tIns="0" rIns="0" bIns="0" rtlCol="0" anchor="ctr"/>
+          <a:lstStyle/>
+          <a:p>
+            <a:pPr indent="0" marL="0">
+              <a:buNone/>
             </a:pPr>
             <a:r>
               <a:rPr lang="en-US" sz="1400" dirty="0">
                 <a:solidFill>
-                  <a:schemeClr val="tx2"/>
-                </a:solidFill>
-              </a:rPr>
-              <a:t>Beats the "same month last year" guess at both history lengths</a:t>
+                  <a:schemeClr val="bg2"/>
+                </a:solidFill>
+              </a:rPr>
+              <a:t>forecast accuracy on 31 real series</a:t>
             </a:r>
             <a:endParaRPr lang="en-US" sz="1400" dirty="0"/>
           </a:p>
-          <a:p>
-            <a:pPr marL="342900" indent="-342900">
-              <a:spcAft>
-                <a:spcPts val="800"/>
-              </a:spcAft>
-              <a:buSzPct val="100000"/>
-              <a:buChar char="•"/>
+        </p:txBody>
+      </p:sp>
+      <p:sp>
+        <p:nvSpPr>
+          <p:cNvPr id="26" name="Text 23"/>
+          <p:cNvSpPr txBox="1"/>
+          <p:nvPr/>
+        </p:nvSpPr>
+        <p:spPr>
+          <a:xfrm>
+            <a:off x="4434840" y="4956048"/>
+            <a:ext cx="3383280" cy="594360"/>
+          </a:xfrm>
+          <a:prstGeom prst="rect">
+            <a:avLst/>
+          </a:prstGeom>
+          <a:noFill/>
+          <a:ln/>
+        </p:spPr>
+        <p:txBody>
+          <a:bodyPr wrap="square" lIns="0" tIns="0" rIns="0" bIns="0" rtlCol="0" anchor="ctr"/>
+          <a:lstStyle/>
+          <a:p>
+            <a:pPr indent="0" marL="0">
+              <a:buNone/>
+            </a:pPr>
+            <a:r>
+              <a:rPr lang="en-US" sz="3200" b="1" dirty="0">
+                <a:solidFill>
+                  <a:schemeClr val="bg1"/>
+                </a:solidFill>
+              </a:rPr>
+              <a:t>4.6% vs 6.4%</a:t>
+            </a:r>
+            <a:endParaRPr lang="en-US" sz="3200" dirty="0"/>
+          </a:p>
+        </p:txBody>
+      </p:sp>
+      <p:sp>
+        <p:nvSpPr>
+          <p:cNvPr id="27" name="Text 24"/>
+          <p:cNvSpPr txBox="1"/>
+          <p:nvPr/>
+        </p:nvSpPr>
+        <p:spPr>
+          <a:xfrm>
+            <a:off x="4434840" y="5577840"/>
+            <a:ext cx="3383280" cy="365760"/>
+          </a:xfrm>
+          <a:prstGeom prst="rect">
+            <a:avLst/>
+          </a:prstGeom>
+          <a:noFill/>
+          <a:ln/>
+        </p:spPr>
+        <p:txBody>
+          <a:bodyPr wrap="square" lIns="0" tIns="0" rIns="0" bIns="0" rtlCol="0" anchor="ctr"/>
+          <a:lstStyle/>
+          <a:p>
+            <a:pPr indent="0" marL="0">
+              <a:buNone/>
             </a:pPr>
             <a:r>
               <a:rPr lang="en-US" sz="1400" dirty="0">
                 <a:solidFill>
-                  <a:schemeClr val="tx2"/>
-                </a:solidFill>
-              </a:rPr>
-              <a:t>The likely range held the real value 80% and 83% of the time, as designed</a:t>
+                  <a:schemeClr val="bg2"/>
+                </a:solidFill>
+              </a:rPr>
+              <a:t>average miss: ours vs last year's guess</a:t>
             </a:r>
             <a:endParaRPr lang="en-US" sz="1400" dirty="0"/>
           </a:p>
-          <a:p>
-            <a:pPr marL="342900" indent="-342900">
-              <a:spcAft>
-                <a:spcPts val="800"/>
-              </a:spcAft>
-              <a:buSzPct val="100000"/>
-              <a:buChar char="•"/>
+        </p:txBody>
+      </p:sp>
+      <p:sp>
+        <p:nvSpPr>
+          <p:cNvPr id="28" name="Text 25"/>
+          <p:cNvSpPr txBox="1"/>
+          <p:nvPr/>
+        </p:nvSpPr>
+        <p:spPr>
+          <a:xfrm>
+            <a:off x="8092440" y="4956048"/>
+            <a:ext cx="3383280" cy="594360"/>
+          </a:xfrm>
+          <a:prstGeom prst="rect">
+            <a:avLst/>
+          </a:prstGeom>
+          <a:noFill/>
+          <a:ln/>
+        </p:spPr>
+        <p:txBody>
+          <a:bodyPr wrap="square" lIns="0" tIns="0" rIns="0" bIns="0" rtlCol="0" anchor="ctr"/>
+          <a:lstStyle/>
+          <a:p>
+            <a:pPr indent="0" marL="0">
+              <a:buNone/>
+            </a:pPr>
+            <a:r>
+              <a:rPr lang="en-US" sz="3200" b="1" dirty="0">
+                <a:solidFill>
+                  <a:schemeClr val="bg1"/>
+                </a:solidFill>
+              </a:rPr>
+              <a:t>8 in 10</a:t>
+            </a:r>
+            <a:endParaRPr lang="en-US" sz="3200" dirty="0"/>
+          </a:p>
+        </p:txBody>
+      </p:sp>
+      <p:sp>
+        <p:nvSpPr>
+          <p:cNvPr id="29" name="Text 26"/>
+          <p:cNvSpPr txBox="1"/>
+          <p:nvPr/>
+        </p:nvSpPr>
+        <p:spPr>
+          <a:xfrm>
+            <a:off x="8092440" y="5577840"/>
+            <a:ext cx="3383280" cy="365760"/>
+          </a:xfrm>
+          <a:prstGeom prst="rect">
+            <a:avLst/>
+          </a:prstGeom>
+          <a:noFill/>
+          <a:ln/>
+        </p:spPr>
+        <p:txBody>
+          <a:bodyPr wrap="square" lIns="0" tIns="0" rIns="0" bIns="0" rtlCol="0" anchor="ctr"/>
+          <a:lstStyle/>
+          <a:p>
+            <a:pPr indent="0" marL="0">
+              <a:buNone/>
             </a:pPr>
             <a:r>
               <a:rPr lang="en-US" sz="1400" dirty="0">
                 <a:solidFill>
-                  <a:schemeClr val="tx2"/>
-                </a:solidFill>
-              </a:rPr>
-              <a:t>These are national totals; one shop is bumpier and will score lower</a:t>
-            </a:r>
-            <a:endParaRPr lang="en-US" sz="1400" dirty="0"/>
-          </a:p>
-          <a:p>
-            <a:pPr marL="342900" indent="-342900">
-              <a:spcAft>
-                <a:spcPts val="800"/>
-              </a:spcAft>
-              <a:buSzPct val="100000"/>
-              <a:buChar char="•"/>
-            </a:pPr>
-            <a:r>
-              <a:rPr lang="en-US" sz="1400" dirty="0">
-                <a:solidFill>
-                  <a:schemeClr val="tx2"/>
-                </a:solidFill>
-              </a:rPr>
-              <a:t>So each client sees a test on their own last months</a:t>
+                  <a:schemeClr val="bg2"/>
+                </a:solidFill>
+              </a:rPr>
+              <a:t>times the range held the real value</a:t>
             </a:r>
             <a:endParaRPr lang="en-US" sz="1400" dirty="0"/>
           </a:p>

</xml_diff>